<commit_message>
Refine external AI execution workflow figure
</commit_message>
<xml_diff>
--- a/opening/slides/opening_defense_20260812_v8.pptx
+++ b/opening/slides/opening_defense_20260812_v8.pptx
@@ -2,33 +2,33 @@
 <file path=ppt/presentation.xml><?xml version="1.0" encoding="utf-8"?>
 <p:presentation xmlns:p="http://schemas.openxmlformats.org/presentationml/2006/main">
   <p:sldMasterIdLst>
-    <p:sldMasterId xmlns:r="http://schemas.openxmlformats.org/officeDocument/2006/relationships" id="2147483648" r:id="Rdd8448b0bdc84a5c"/>
-    <p:sldMasterId xmlns:r="http://schemas.openxmlformats.org/officeDocument/2006/relationships" id="2147483653" r:id="R1d6b495a072a4cb0"/>
+    <p:sldMasterId xmlns:r="http://schemas.openxmlformats.org/officeDocument/2006/relationships" id="2147483648" r:id="Rce72d355ea664ac8"/>
+    <p:sldMasterId xmlns:r="http://schemas.openxmlformats.org/officeDocument/2006/relationships" id="2147483653" r:id="Rbc1d9ea40f504ba0"/>
   </p:sldMasterIdLst>
   <p:notesMasterIdLst>
-    <p:notesMasterId xmlns:r="http://schemas.openxmlformats.org/officeDocument/2006/relationships" r:id="Rc15d7afe62434f3b"/>
+    <p:notesMasterId xmlns:r="http://schemas.openxmlformats.org/officeDocument/2006/relationships" r:id="R68bdd16c7ffe49a2"/>
   </p:notesMasterIdLst>
   <p:sldIdLst>
-    <p:sldId xmlns:r="http://schemas.openxmlformats.org/officeDocument/2006/relationships" id="256" r:id="Rd655808875c24557"/>
-    <p:sldId xmlns:r="http://schemas.openxmlformats.org/officeDocument/2006/relationships" id="257" r:id="R948b9a0839164272"/>
-    <p:sldId xmlns:r="http://schemas.openxmlformats.org/officeDocument/2006/relationships" id="258" r:id="R38b18f250a444196"/>
-    <p:sldId xmlns:r="http://schemas.openxmlformats.org/officeDocument/2006/relationships" id="259" r:id="R174b1da3f91f48b0"/>
-    <p:sldId xmlns:r="http://schemas.openxmlformats.org/officeDocument/2006/relationships" id="260" r:id="R304daeb553214439"/>
-    <p:sldId xmlns:r="http://schemas.openxmlformats.org/officeDocument/2006/relationships" id="261" r:id="R6e4768e284914903"/>
-    <p:sldId xmlns:r="http://schemas.openxmlformats.org/officeDocument/2006/relationships" id="262" r:id="Rbd34ba2f785341c0"/>
-    <p:sldId xmlns:r="http://schemas.openxmlformats.org/officeDocument/2006/relationships" id="263" r:id="Rc94f3a7f9be04763"/>
-    <p:sldId xmlns:r="http://schemas.openxmlformats.org/officeDocument/2006/relationships" id="264" r:id="Rd7a96451c6f04c09"/>
-    <p:sldId xmlns:r="http://schemas.openxmlformats.org/officeDocument/2006/relationships" id="265" r:id="R30d7770ed77744a1"/>
-    <p:sldId xmlns:r="http://schemas.openxmlformats.org/officeDocument/2006/relationships" id="266" r:id="R411b0ef6e0d74755"/>
-    <p:sldId xmlns:r="http://schemas.openxmlformats.org/officeDocument/2006/relationships" id="267" r:id="R0de47b6d39f14cd2"/>
-    <p:sldId xmlns:r="http://schemas.openxmlformats.org/officeDocument/2006/relationships" id="268" r:id="Ra9e5b6992ac645a2"/>
-    <p:sldId xmlns:r="http://schemas.openxmlformats.org/officeDocument/2006/relationships" id="269" r:id="R09642e5b5537429b"/>
-    <p:sldId xmlns:r="http://schemas.openxmlformats.org/officeDocument/2006/relationships" id="270" r:id="R417ef020b67b421a"/>
-    <p:sldId xmlns:r="http://schemas.openxmlformats.org/officeDocument/2006/relationships" id="271" r:id="R168cb3d896c34849"/>
-    <p:sldId xmlns:r="http://schemas.openxmlformats.org/officeDocument/2006/relationships" id="272" r:id="R983153ac19584590"/>
-    <p:sldId xmlns:r="http://schemas.openxmlformats.org/officeDocument/2006/relationships" id="273" r:id="Rf982d532d6674b7f"/>
-    <p:sldId xmlns:r="http://schemas.openxmlformats.org/officeDocument/2006/relationships" id="274" r:id="Rb54ccf68c97445a8"/>
-    <p:sldId xmlns:r="http://schemas.openxmlformats.org/officeDocument/2006/relationships" id="275" r:id="Rfe68cd71ff294a77"/>
+    <p:sldId xmlns:r="http://schemas.openxmlformats.org/officeDocument/2006/relationships" id="256" r:id="R50983ecafcf14dcf"/>
+    <p:sldId xmlns:r="http://schemas.openxmlformats.org/officeDocument/2006/relationships" id="257" r:id="Rf7bbe82950ba4979"/>
+    <p:sldId xmlns:r="http://schemas.openxmlformats.org/officeDocument/2006/relationships" id="258" r:id="Rabfa3ab8c23943a9"/>
+    <p:sldId xmlns:r="http://schemas.openxmlformats.org/officeDocument/2006/relationships" id="259" r:id="R0dfb554c83754406"/>
+    <p:sldId xmlns:r="http://schemas.openxmlformats.org/officeDocument/2006/relationships" id="260" r:id="R3549f47f3c2e4b45"/>
+    <p:sldId xmlns:r="http://schemas.openxmlformats.org/officeDocument/2006/relationships" id="261" r:id="R733d87e356f94869"/>
+    <p:sldId xmlns:r="http://schemas.openxmlformats.org/officeDocument/2006/relationships" id="262" r:id="R2175f2f0888d4941"/>
+    <p:sldId xmlns:r="http://schemas.openxmlformats.org/officeDocument/2006/relationships" id="263" r:id="R137804fe6a244005"/>
+    <p:sldId xmlns:r="http://schemas.openxmlformats.org/officeDocument/2006/relationships" id="264" r:id="Rb99e2c4ec7414102"/>
+    <p:sldId xmlns:r="http://schemas.openxmlformats.org/officeDocument/2006/relationships" id="265" r:id="Rc843d0796df84b2f"/>
+    <p:sldId xmlns:r="http://schemas.openxmlformats.org/officeDocument/2006/relationships" id="266" r:id="Rdb59f9e8f1554ebe"/>
+    <p:sldId xmlns:r="http://schemas.openxmlformats.org/officeDocument/2006/relationships" id="267" r:id="R68efcb045a4d4b0f"/>
+    <p:sldId xmlns:r="http://schemas.openxmlformats.org/officeDocument/2006/relationships" id="268" r:id="R5ef6590c25ef489e"/>
+    <p:sldId xmlns:r="http://schemas.openxmlformats.org/officeDocument/2006/relationships" id="269" r:id="R770ea0bc2fa24c79"/>
+    <p:sldId xmlns:r="http://schemas.openxmlformats.org/officeDocument/2006/relationships" id="270" r:id="R02628d8754414ea1"/>
+    <p:sldId xmlns:r="http://schemas.openxmlformats.org/officeDocument/2006/relationships" id="271" r:id="Rb3954c6feec84ded"/>
+    <p:sldId xmlns:r="http://schemas.openxmlformats.org/officeDocument/2006/relationships" id="272" r:id="R31feab7d43d048d4"/>
+    <p:sldId xmlns:r="http://schemas.openxmlformats.org/officeDocument/2006/relationships" id="273" r:id="Rf59f2a628e504bed"/>
+    <p:sldId xmlns:r="http://schemas.openxmlformats.org/officeDocument/2006/relationships" id="274" r:id="R8986b2644e344ed1"/>
+    <p:sldId xmlns:r="http://schemas.openxmlformats.org/officeDocument/2006/relationships" id="275" r:id="R0ab7417974d94b11"/>
   </p:sldIdLst>
   <p:sldSz cx="12192000" cy="6858000"/>
   <p:notesSz cx="6858000" cy="9144000"/>
@@ -2858,7 +2858,7 @@
           <p:nvPr/>
         </p:nvPicPr>
         <p:blipFill>
-          <a:blip xmlns:r="http://schemas.openxmlformats.org/officeDocument/2006/relationships" xmlns:a="http://schemas.openxmlformats.org/drawingml/2006/main" r:embed="R03b708a7fd924ea1"/>
+          <a:blip xmlns:r="http://schemas.openxmlformats.org/officeDocument/2006/relationships" xmlns:a="http://schemas.openxmlformats.org/drawingml/2006/main" r:embed="R928a18544530494f"/>
           <a:stretch xmlns:a="http://schemas.openxmlformats.org/drawingml/2006/main">
             <a:fillRect l="0" t="0" r="0" b="0"/>
           </a:stretch>
@@ -4919,7 +4919,7 @@
           <p:nvPr/>
         </p:nvPicPr>
         <p:blipFill>
-          <a:blip xmlns:r="http://schemas.openxmlformats.org/officeDocument/2006/relationships" xmlns:a="http://schemas.openxmlformats.org/drawingml/2006/main" r:embed="Raeb7dc7e61c54727"/>
+          <a:blip xmlns:r="http://schemas.openxmlformats.org/officeDocument/2006/relationships" xmlns:a="http://schemas.openxmlformats.org/drawingml/2006/main" r:embed="Rd30c18b903f44c2d"/>
           <a:stretch xmlns:a="http://schemas.openxmlformats.org/drawingml/2006/main">
             <a:fillRect l="0" t="0" r="0" b="0"/>
           </a:stretch>
@@ -5345,7 +5345,7 @@
           <p:nvPr/>
         </p:nvPicPr>
         <p:blipFill>
-          <a:blip xmlns:r="http://schemas.openxmlformats.org/officeDocument/2006/relationships" xmlns:a="http://schemas.openxmlformats.org/drawingml/2006/main" r:embed="Rc925ab26e8974bed"/>
+          <a:blip xmlns:r="http://schemas.openxmlformats.org/officeDocument/2006/relationships" xmlns:a="http://schemas.openxmlformats.org/drawingml/2006/main" r:embed="Red8476cfabed41fc"/>
           <a:stretch xmlns:a="http://schemas.openxmlformats.org/drawingml/2006/main">
             <a:fillRect l="0" t="0" r="0" b="0"/>
           </a:stretch>
@@ -6555,7 +6555,7 @@
           <p:nvPr/>
         </p:nvPicPr>
         <p:blipFill>
-          <a:blip xmlns:r="http://schemas.openxmlformats.org/officeDocument/2006/relationships" xmlns:a="http://schemas.openxmlformats.org/drawingml/2006/main" r:embed="Rb3e4a043911e40fa"/>
+          <a:blip xmlns:r="http://schemas.openxmlformats.org/officeDocument/2006/relationships" xmlns:a="http://schemas.openxmlformats.org/drawingml/2006/main" r:embed="R531be39d3f4d4417"/>
           <a:stretch xmlns:a="http://schemas.openxmlformats.org/drawingml/2006/main">
             <a:fillRect l="0" t="0" r="0" b="0"/>
           </a:stretch>
@@ -7166,10 +7166,10 @@
   </p:cSld>
   <p:clrMap bg1="lt1" tx1="dk1" bg2="lt2" tx2="dk2" accent1="accent1" accent2="accent2" accent3="accent3" accent4="accent4" accent5="accent5" accent6="accent6" hlink="hlink" folHlink="folHlink"/>
   <p:sldLayoutIdLst>
-    <p:sldLayoutId xmlns:r="http://schemas.openxmlformats.org/officeDocument/2006/relationships" id="2147483649" r:id="R7a07e8cdc2ab40f2"/>
-    <p:sldLayoutId xmlns:r="http://schemas.openxmlformats.org/officeDocument/2006/relationships" id="2147483650" r:id="Rbd94f8b665a54758"/>
-    <p:sldLayoutId xmlns:r="http://schemas.openxmlformats.org/officeDocument/2006/relationships" id="2147483651" r:id="R9c6773e76da64dd2"/>
-    <p:sldLayoutId xmlns:r="http://schemas.openxmlformats.org/officeDocument/2006/relationships" id="2147483652" r:id="Rb7ce02ce0c854b01"/>
+    <p:sldLayoutId xmlns:r="http://schemas.openxmlformats.org/officeDocument/2006/relationships" id="2147483649" r:id="R6774aaf4022f4dde"/>
+    <p:sldLayoutId xmlns:r="http://schemas.openxmlformats.org/officeDocument/2006/relationships" id="2147483650" r:id="R2907cd1275a145f0"/>
+    <p:sldLayoutId xmlns:r="http://schemas.openxmlformats.org/officeDocument/2006/relationships" id="2147483651" r:id="Rc07ac18b63374e4b"/>
+    <p:sldLayoutId xmlns:r="http://schemas.openxmlformats.org/officeDocument/2006/relationships" id="2147483652" r:id="R069991e97ab84089"/>
   </p:sldLayoutIdLst>
   <p:hf hdr="0" ftr="0" dt="0"/>
   <p:txStyles>
@@ -7932,7 +7932,7 @@
           <p:nvPr/>
         </p:nvPicPr>
         <p:blipFill>
-          <a:blip xmlns:r="http://schemas.openxmlformats.org/officeDocument/2006/relationships" xmlns:a="http://schemas.openxmlformats.org/drawingml/2006/main" r:embed="R4ac25cf3ef1c48c5"/>
+          <a:blip xmlns:r="http://schemas.openxmlformats.org/officeDocument/2006/relationships" xmlns:a="http://schemas.openxmlformats.org/drawingml/2006/main" r:embed="Rcec52703fe3a4ce6"/>
           <a:stretch xmlns:a="http://schemas.openxmlformats.org/drawingml/2006/main">
             <a:fillRect l="0" t="0" r="0" b="0"/>
           </a:stretch>
@@ -8235,17 +8235,17 @@
   </p:cSld>
   <p:clrMap bg1="lt1" tx1="dk1" bg2="lt2" tx2="dk2" accent1="accent1" accent2="accent2" accent3="accent3" accent4="accent4" accent5="accent5" accent6="accent6" hlink="hlink" folHlink="folHlink"/>
   <p:sldLayoutIdLst>
-    <p:sldLayoutId xmlns:r="http://schemas.openxmlformats.org/officeDocument/2006/relationships" id="2147483654" r:id="R0b5515b1088643ce"/>
-    <p:sldLayoutId xmlns:r="http://schemas.openxmlformats.org/officeDocument/2006/relationships" id="2147483655" r:id="Rb3d2e5dbda274bf9"/>
-    <p:sldLayoutId xmlns:r="http://schemas.openxmlformats.org/officeDocument/2006/relationships" id="2147483656" r:id="R63985c2401234ee7"/>
-    <p:sldLayoutId xmlns:r="http://schemas.openxmlformats.org/officeDocument/2006/relationships" id="2147483657" r:id="Re68fef22c2b4446e"/>
-    <p:sldLayoutId xmlns:r="http://schemas.openxmlformats.org/officeDocument/2006/relationships" id="2147483658" r:id="R9965c77987b5450c"/>
-    <p:sldLayoutId xmlns:r="http://schemas.openxmlformats.org/officeDocument/2006/relationships" id="2147483659" r:id="Rbeab0bc0b2724ee2"/>
-    <p:sldLayoutId xmlns:r="http://schemas.openxmlformats.org/officeDocument/2006/relationships" id="2147483660" r:id="R846807ae924e4d75"/>
-    <p:sldLayoutId xmlns:r="http://schemas.openxmlformats.org/officeDocument/2006/relationships" id="2147483661" r:id="R9b290dcb7641499f"/>
-    <p:sldLayoutId xmlns:r="http://schemas.openxmlformats.org/officeDocument/2006/relationships" id="2147483662" r:id="Re5bea50d39ea4a02"/>
-    <p:sldLayoutId xmlns:r="http://schemas.openxmlformats.org/officeDocument/2006/relationships" id="2147483663" r:id="R095c4fd146f444e9"/>
-    <p:sldLayoutId xmlns:r="http://schemas.openxmlformats.org/officeDocument/2006/relationships" id="2147483664" r:id="R6dba9ac03a7748bd"/>
+    <p:sldLayoutId xmlns:r="http://schemas.openxmlformats.org/officeDocument/2006/relationships" id="2147483654" r:id="R611ae9fdfc814c62"/>
+    <p:sldLayoutId xmlns:r="http://schemas.openxmlformats.org/officeDocument/2006/relationships" id="2147483655" r:id="Rf02677ac07e74a1d"/>
+    <p:sldLayoutId xmlns:r="http://schemas.openxmlformats.org/officeDocument/2006/relationships" id="2147483656" r:id="R6a04485c49aa4d1d"/>
+    <p:sldLayoutId xmlns:r="http://schemas.openxmlformats.org/officeDocument/2006/relationships" id="2147483657" r:id="R5106855820e247d9"/>
+    <p:sldLayoutId xmlns:r="http://schemas.openxmlformats.org/officeDocument/2006/relationships" id="2147483658" r:id="R7218614daae14abb"/>
+    <p:sldLayoutId xmlns:r="http://schemas.openxmlformats.org/officeDocument/2006/relationships" id="2147483659" r:id="R20530dce48bc4a0b"/>
+    <p:sldLayoutId xmlns:r="http://schemas.openxmlformats.org/officeDocument/2006/relationships" id="2147483660" r:id="R6b80278f2ea64335"/>
+    <p:sldLayoutId xmlns:r="http://schemas.openxmlformats.org/officeDocument/2006/relationships" id="2147483661" r:id="R90c7bc8638264ed2"/>
+    <p:sldLayoutId xmlns:r="http://schemas.openxmlformats.org/officeDocument/2006/relationships" id="2147483662" r:id="R8647a99860a8403c"/>
+    <p:sldLayoutId xmlns:r="http://schemas.openxmlformats.org/officeDocument/2006/relationships" id="2147483663" r:id="Rdcbed58325dd4af6"/>
+    <p:sldLayoutId xmlns:r="http://schemas.openxmlformats.org/officeDocument/2006/relationships" id="2147483664" r:id="R29f1df74458b4609"/>
   </p:sldLayoutIdLst>
   <p:hf hdr="0" ftr="0" dt="0"/>
   <p:txStyles>
@@ -9814,7 +9814,7 @@
           <p:nvPr/>
         </p:nvPicPr>
         <p:blipFill>
-          <a:blip xmlns:r="http://schemas.openxmlformats.org/officeDocument/2006/relationships" xmlns:a="http://schemas.openxmlformats.org/drawingml/2006/main" r:embed="R26ee1c95fdae4a9f"/>
+          <a:blip xmlns:r="http://schemas.openxmlformats.org/officeDocument/2006/relationships" xmlns:a="http://schemas.openxmlformats.org/drawingml/2006/main" r:embed="R41eb5723eb874752"/>
           <a:stretch xmlns:a="http://schemas.openxmlformats.org/drawingml/2006/main"/>
         </p:blipFill>
         <p:spPr>
@@ -10167,7 +10167,7 @@
           <p:nvPr/>
         </p:nvPicPr>
         <p:blipFill>
-          <a:blip xmlns:r="http://schemas.openxmlformats.org/officeDocument/2006/relationships" xmlns:a="http://schemas.openxmlformats.org/drawingml/2006/main" r:embed="R39f7f71dad254b2f"/>
+          <a:blip xmlns:r="http://schemas.openxmlformats.org/officeDocument/2006/relationships" xmlns:a="http://schemas.openxmlformats.org/drawingml/2006/main" r:embed="Rca2910752b5f4d2a"/>
           <a:stretch xmlns:a="http://schemas.openxmlformats.org/drawingml/2006/main"/>
         </p:blipFill>
         <p:spPr>
@@ -10520,7 +10520,7 @@
           <p:nvPr/>
         </p:nvPicPr>
         <p:blipFill>
-          <a:blip xmlns:r="http://schemas.openxmlformats.org/officeDocument/2006/relationships" xmlns:a="http://schemas.openxmlformats.org/drawingml/2006/main" r:embed="Rf642e2d562b84ed2"/>
+          <a:blip xmlns:r="http://schemas.openxmlformats.org/officeDocument/2006/relationships" xmlns:a="http://schemas.openxmlformats.org/drawingml/2006/main" r:embed="R129e4362feae4e61"/>
           <a:stretch xmlns:a="http://schemas.openxmlformats.org/drawingml/2006/main"/>
         </p:blipFill>
         <p:spPr>
@@ -10873,7 +10873,7 @@
           <p:nvPr/>
         </p:nvPicPr>
         <p:blipFill>
-          <a:blip xmlns:r="http://schemas.openxmlformats.org/officeDocument/2006/relationships" xmlns:a="http://schemas.openxmlformats.org/drawingml/2006/main" r:embed="Rb8d2c808f03f4ca5"/>
+          <a:blip xmlns:r="http://schemas.openxmlformats.org/officeDocument/2006/relationships" xmlns:a="http://schemas.openxmlformats.org/drawingml/2006/main" r:embed="R627c7a3b93a446a1"/>
           <a:stretch xmlns:a="http://schemas.openxmlformats.org/drawingml/2006/main"/>
         </p:blipFill>
         <p:spPr>
@@ -11226,7 +11226,7 @@
           <p:nvPr/>
         </p:nvPicPr>
         <p:blipFill>
-          <a:blip xmlns:r="http://schemas.openxmlformats.org/officeDocument/2006/relationships" xmlns:a="http://schemas.openxmlformats.org/drawingml/2006/main" r:embed="R62b0644f98104639"/>
+          <a:blip xmlns:r="http://schemas.openxmlformats.org/officeDocument/2006/relationships" xmlns:a="http://schemas.openxmlformats.org/drawingml/2006/main" r:embed="R545a7d124f324195"/>
           <a:stretch xmlns:a="http://schemas.openxmlformats.org/drawingml/2006/main"/>
         </p:blipFill>
         <p:spPr>
@@ -11579,7 +11579,7 @@
           <p:nvPr/>
         </p:nvPicPr>
         <p:blipFill>
-          <a:blip xmlns:r="http://schemas.openxmlformats.org/officeDocument/2006/relationships" xmlns:a="http://schemas.openxmlformats.org/drawingml/2006/main" r:embed="R63ff421c606749ac"/>
+          <a:blip xmlns:r="http://schemas.openxmlformats.org/officeDocument/2006/relationships" xmlns:a="http://schemas.openxmlformats.org/drawingml/2006/main" r:embed="R9067587eee1c4f3f"/>
           <a:stretch xmlns:a="http://schemas.openxmlformats.org/drawingml/2006/main"/>
         </p:blipFill>
         <p:spPr>
@@ -11932,7 +11932,7 @@
           <p:nvPr/>
         </p:nvPicPr>
         <p:blipFill>
-          <a:blip xmlns:r="http://schemas.openxmlformats.org/officeDocument/2006/relationships" xmlns:a="http://schemas.openxmlformats.org/drawingml/2006/main" r:embed="R8b0f433c81bf4faa"/>
+          <a:blip xmlns:r="http://schemas.openxmlformats.org/officeDocument/2006/relationships" xmlns:a="http://schemas.openxmlformats.org/drawingml/2006/main" r:embed="Rfac9d68941e84847"/>
           <a:stretch xmlns:a="http://schemas.openxmlformats.org/drawingml/2006/main"/>
         </p:blipFill>
         <p:spPr>
@@ -12285,7 +12285,7 @@
           <p:nvPr/>
         </p:nvPicPr>
         <p:blipFill>
-          <a:blip xmlns:r="http://schemas.openxmlformats.org/officeDocument/2006/relationships" xmlns:a="http://schemas.openxmlformats.org/drawingml/2006/main" r:embed="R87a004777cc44819"/>
+          <a:blip xmlns:r="http://schemas.openxmlformats.org/officeDocument/2006/relationships" xmlns:a="http://schemas.openxmlformats.org/drawingml/2006/main" r:embed="R5c0b466f190841ec"/>
           <a:stretch xmlns:a="http://schemas.openxmlformats.org/drawingml/2006/main"/>
         </p:blipFill>
         <p:spPr>
@@ -12638,7 +12638,7 @@
           <p:nvPr/>
         </p:nvPicPr>
         <p:blipFill>
-          <a:blip xmlns:r="http://schemas.openxmlformats.org/officeDocument/2006/relationships" xmlns:a="http://schemas.openxmlformats.org/drawingml/2006/main" r:embed="Rb08a29b08f624cc7"/>
+          <a:blip xmlns:r="http://schemas.openxmlformats.org/officeDocument/2006/relationships" xmlns:a="http://schemas.openxmlformats.org/drawingml/2006/main" r:embed="Ra733eb0fc8bb4aac"/>
           <a:stretch xmlns:a="http://schemas.openxmlformats.org/drawingml/2006/main"/>
         </p:blipFill>
         <p:spPr>
@@ -12791,7 +12791,7 @@
           <p:nvPr/>
         </p:nvPicPr>
         <p:blipFill>
-          <a:blip xmlns:r="http://schemas.openxmlformats.org/officeDocument/2006/relationships" xmlns:a="http://schemas.openxmlformats.org/drawingml/2006/main" r:embed="R3bab1c192df34207"/>
+          <a:blip xmlns:r="http://schemas.openxmlformats.org/officeDocument/2006/relationships" xmlns:a="http://schemas.openxmlformats.org/drawingml/2006/main" r:embed="R37717c8eb71a42f8"/>
           <a:stretch xmlns:a="http://schemas.openxmlformats.org/drawingml/2006/main"/>
         </p:blipFill>
         <p:spPr>
@@ -13320,7 +13320,7 @@
           <p:nvPr/>
         </p:nvPicPr>
         <p:blipFill>
-          <a:blip xmlns:r="http://schemas.openxmlformats.org/officeDocument/2006/relationships" xmlns:a="http://schemas.openxmlformats.org/drawingml/2006/main" r:embed="Ra463ee800f504bd0"/>
+          <a:blip xmlns:r="http://schemas.openxmlformats.org/officeDocument/2006/relationships" xmlns:a="http://schemas.openxmlformats.org/drawingml/2006/main" r:embed="R7e3b754568364ce2"/>
           <a:stretch xmlns:a="http://schemas.openxmlformats.org/drawingml/2006/main"/>
         </p:blipFill>
         <p:spPr>
@@ -13473,7 +13473,7 @@
           <p:nvPr/>
         </p:nvPicPr>
         <p:blipFill>
-          <a:blip xmlns:r="http://schemas.openxmlformats.org/officeDocument/2006/relationships" xmlns:a="http://schemas.openxmlformats.org/drawingml/2006/main" r:embed="Rab9668f73aa845a6"/>
+          <a:blip xmlns:r="http://schemas.openxmlformats.org/officeDocument/2006/relationships" xmlns:a="http://schemas.openxmlformats.org/drawingml/2006/main" r:embed="R57a387d195ea4564"/>
           <a:stretch xmlns:a="http://schemas.openxmlformats.org/drawingml/2006/main"/>
         </p:blipFill>
         <p:spPr>
@@ -13826,7 +13826,7 @@
           <p:nvPr/>
         </p:nvPicPr>
         <p:blipFill>
-          <a:blip xmlns:r="http://schemas.openxmlformats.org/officeDocument/2006/relationships" xmlns:a="http://schemas.openxmlformats.org/drawingml/2006/main" r:embed="Rf1eb7723efba4b0c"/>
+          <a:blip xmlns:r="http://schemas.openxmlformats.org/officeDocument/2006/relationships" xmlns:a="http://schemas.openxmlformats.org/drawingml/2006/main" r:embed="R2aad5ad184304fe1"/>
           <a:stretch xmlns:a="http://schemas.openxmlformats.org/drawingml/2006/main"/>
         </p:blipFill>
         <p:spPr>
@@ -14179,7 +14179,7 @@
           <p:nvPr/>
         </p:nvPicPr>
         <p:blipFill>
-          <a:blip xmlns:r="http://schemas.openxmlformats.org/officeDocument/2006/relationships" xmlns:a="http://schemas.openxmlformats.org/drawingml/2006/main" r:embed="R6e0dfb3f934645a5"/>
+          <a:blip xmlns:r="http://schemas.openxmlformats.org/officeDocument/2006/relationships" xmlns:a="http://schemas.openxmlformats.org/drawingml/2006/main" r:embed="Rd009f345a0a84958"/>
           <a:stretch xmlns:a="http://schemas.openxmlformats.org/drawingml/2006/main"/>
         </p:blipFill>
         <p:spPr>
@@ -14532,7 +14532,7 @@
           <p:nvPr/>
         </p:nvPicPr>
         <p:blipFill>
-          <a:blip xmlns:r="http://schemas.openxmlformats.org/officeDocument/2006/relationships" xmlns:a="http://schemas.openxmlformats.org/drawingml/2006/main" r:embed="Rbbdc4977ae6d42c1"/>
+          <a:blip xmlns:r="http://schemas.openxmlformats.org/officeDocument/2006/relationships" xmlns:a="http://schemas.openxmlformats.org/drawingml/2006/main" r:embed="Rf2424530150f4d41"/>
           <a:stretch xmlns:a="http://schemas.openxmlformats.org/drawingml/2006/main"/>
         </p:blipFill>
         <p:spPr>
@@ -14885,7 +14885,7 @@
           <p:nvPr/>
         </p:nvPicPr>
         <p:blipFill>
-          <a:blip xmlns:r="http://schemas.openxmlformats.org/officeDocument/2006/relationships" xmlns:a="http://schemas.openxmlformats.org/drawingml/2006/main" r:embed="R5956df8cd9be4aab"/>
+          <a:blip xmlns:r="http://schemas.openxmlformats.org/officeDocument/2006/relationships" xmlns:a="http://schemas.openxmlformats.org/drawingml/2006/main" r:embed="Rd1d12e4e8f75484f"/>
           <a:stretch xmlns:a="http://schemas.openxmlformats.org/drawingml/2006/main"/>
         </p:blipFill>
         <p:spPr>
@@ -15238,7 +15238,7 @@
           <p:nvPr/>
         </p:nvPicPr>
         <p:blipFill>
-          <a:blip xmlns:r="http://schemas.openxmlformats.org/officeDocument/2006/relationships" xmlns:a="http://schemas.openxmlformats.org/drawingml/2006/main" r:embed="R02f00f6bc29f49fb"/>
+          <a:blip xmlns:r="http://schemas.openxmlformats.org/officeDocument/2006/relationships" xmlns:a="http://schemas.openxmlformats.org/drawingml/2006/main" r:embed="Rb7b2c1b6e5f04f13"/>
           <a:stretch xmlns:a="http://schemas.openxmlformats.org/drawingml/2006/main"/>
         </p:blipFill>
         <p:spPr>

</xml_diff>

<commit_message>
Clarify workflow arrows and diagram legend
</commit_message>
<xml_diff>
--- a/opening/slides/opening_defense_20260812_v8.pptx
+++ b/opening/slides/opening_defense_20260812_v8.pptx
@@ -2,33 +2,33 @@
 <file path=ppt/presentation.xml><?xml version="1.0" encoding="utf-8"?>
 <p:presentation xmlns:p="http://schemas.openxmlformats.org/presentationml/2006/main">
   <p:sldMasterIdLst>
-    <p:sldMasterId xmlns:r="http://schemas.openxmlformats.org/officeDocument/2006/relationships" id="2147483648" r:id="Rce72d355ea664ac8"/>
-    <p:sldMasterId xmlns:r="http://schemas.openxmlformats.org/officeDocument/2006/relationships" id="2147483653" r:id="Rbc1d9ea40f504ba0"/>
+    <p:sldMasterId xmlns:r="http://schemas.openxmlformats.org/officeDocument/2006/relationships" id="2147483648" r:id="R393bd8f037f048aa"/>
+    <p:sldMasterId xmlns:r="http://schemas.openxmlformats.org/officeDocument/2006/relationships" id="2147483653" r:id="Rba6f1232c8af4744"/>
   </p:sldMasterIdLst>
   <p:notesMasterIdLst>
-    <p:notesMasterId xmlns:r="http://schemas.openxmlformats.org/officeDocument/2006/relationships" r:id="R68bdd16c7ffe49a2"/>
+    <p:notesMasterId xmlns:r="http://schemas.openxmlformats.org/officeDocument/2006/relationships" r:id="R6290bfe82f554d22"/>
   </p:notesMasterIdLst>
   <p:sldIdLst>
-    <p:sldId xmlns:r="http://schemas.openxmlformats.org/officeDocument/2006/relationships" id="256" r:id="R50983ecafcf14dcf"/>
-    <p:sldId xmlns:r="http://schemas.openxmlformats.org/officeDocument/2006/relationships" id="257" r:id="Rf7bbe82950ba4979"/>
-    <p:sldId xmlns:r="http://schemas.openxmlformats.org/officeDocument/2006/relationships" id="258" r:id="Rabfa3ab8c23943a9"/>
-    <p:sldId xmlns:r="http://schemas.openxmlformats.org/officeDocument/2006/relationships" id="259" r:id="R0dfb554c83754406"/>
-    <p:sldId xmlns:r="http://schemas.openxmlformats.org/officeDocument/2006/relationships" id="260" r:id="R3549f47f3c2e4b45"/>
-    <p:sldId xmlns:r="http://schemas.openxmlformats.org/officeDocument/2006/relationships" id="261" r:id="R733d87e356f94869"/>
-    <p:sldId xmlns:r="http://schemas.openxmlformats.org/officeDocument/2006/relationships" id="262" r:id="R2175f2f0888d4941"/>
-    <p:sldId xmlns:r="http://schemas.openxmlformats.org/officeDocument/2006/relationships" id="263" r:id="R137804fe6a244005"/>
-    <p:sldId xmlns:r="http://schemas.openxmlformats.org/officeDocument/2006/relationships" id="264" r:id="Rb99e2c4ec7414102"/>
-    <p:sldId xmlns:r="http://schemas.openxmlformats.org/officeDocument/2006/relationships" id="265" r:id="Rc843d0796df84b2f"/>
-    <p:sldId xmlns:r="http://schemas.openxmlformats.org/officeDocument/2006/relationships" id="266" r:id="Rdb59f9e8f1554ebe"/>
-    <p:sldId xmlns:r="http://schemas.openxmlformats.org/officeDocument/2006/relationships" id="267" r:id="R68efcb045a4d4b0f"/>
-    <p:sldId xmlns:r="http://schemas.openxmlformats.org/officeDocument/2006/relationships" id="268" r:id="R5ef6590c25ef489e"/>
-    <p:sldId xmlns:r="http://schemas.openxmlformats.org/officeDocument/2006/relationships" id="269" r:id="R770ea0bc2fa24c79"/>
-    <p:sldId xmlns:r="http://schemas.openxmlformats.org/officeDocument/2006/relationships" id="270" r:id="R02628d8754414ea1"/>
-    <p:sldId xmlns:r="http://schemas.openxmlformats.org/officeDocument/2006/relationships" id="271" r:id="Rb3954c6feec84ded"/>
-    <p:sldId xmlns:r="http://schemas.openxmlformats.org/officeDocument/2006/relationships" id="272" r:id="R31feab7d43d048d4"/>
-    <p:sldId xmlns:r="http://schemas.openxmlformats.org/officeDocument/2006/relationships" id="273" r:id="Rf59f2a628e504bed"/>
-    <p:sldId xmlns:r="http://schemas.openxmlformats.org/officeDocument/2006/relationships" id="274" r:id="R8986b2644e344ed1"/>
-    <p:sldId xmlns:r="http://schemas.openxmlformats.org/officeDocument/2006/relationships" id="275" r:id="R0ab7417974d94b11"/>
+    <p:sldId xmlns:r="http://schemas.openxmlformats.org/officeDocument/2006/relationships" id="256" r:id="Rc038a4958a3d494e"/>
+    <p:sldId xmlns:r="http://schemas.openxmlformats.org/officeDocument/2006/relationships" id="257" r:id="R25c4ed090a484228"/>
+    <p:sldId xmlns:r="http://schemas.openxmlformats.org/officeDocument/2006/relationships" id="258" r:id="Rbc41b24c243e4f2d"/>
+    <p:sldId xmlns:r="http://schemas.openxmlformats.org/officeDocument/2006/relationships" id="259" r:id="R8331ed2351b04c1b"/>
+    <p:sldId xmlns:r="http://schemas.openxmlformats.org/officeDocument/2006/relationships" id="260" r:id="R56e95784a3694edc"/>
+    <p:sldId xmlns:r="http://schemas.openxmlformats.org/officeDocument/2006/relationships" id="261" r:id="Raa521acd2d334300"/>
+    <p:sldId xmlns:r="http://schemas.openxmlformats.org/officeDocument/2006/relationships" id="262" r:id="R230e8b451ded48ee"/>
+    <p:sldId xmlns:r="http://schemas.openxmlformats.org/officeDocument/2006/relationships" id="263" r:id="R4730cbd1fb374bc0"/>
+    <p:sldId xmlns:r="http://schemas.openxmlformats.org/officeDocument/2006/relationships" id="264" r:id="R2511c9e2455d426e"/>
+    <p:sldId xmlns:r="http://schemas.openxmlformats.org/officeDocument/2006/relationships" id="265" r:id="R10817e790b0d4cc2"/>
+    <p:sldId xmlns:r="http://schemas.openxmlformats.org/officeDocument/2006/relationships" id="266" r:id="Rd34a589c38264b80"/>
+    <p:sldId xmlns:r="http://schemas.openxmlformats.org/officeDocument/2006/relationships" id="267" r:id="R51f535abe16c4b42"/>
+    <p:sldId xmlns:r="http://schemas.openxmlformats.org/officeDocument/2006/relationships" id="268" r:id="R080d4e8de6084022"/>
+    <p:sldId xmlns:r="http://schemas.openxmlformats.org/officeDocument/2006/relationships" id="269" r:id="R0b46f1bf790c4d20"/>
+    <p:sldId xmlns:r="http://schemas.openxmlformats.org/officeDocument/2006/relationships" id="270" r:id="Re9ff532885cf4dbb"/>
+    <p:sldId xmlns:r="http://schemas.openxmlformats.org/officeDocument/2006/relationships" id="271" r:id="Rd2fc288306b34906"/>
+    <p:sldId xmlns:r="http://schemas.openxmlformats.org/officeDocument/2006/relationships" id="272" r:id="R5d0fdc2cd2494729"/>
+    <p:sldId xmlns:r="http://schemas.openxmlformats.org/officeDocument/2006/relationships" id="273" r:id="Rde1396d33196443e"/>
+    <p:sldId xmlns:r="http://schemas.openxmlformats.org/officeDocument/2006/relationships" id="274" r:id="R11efca1f7e7e4772"/>
+    <p:sldId xmlns:r="http://schemas.openxmlformats.org/officeDocument/2006/relationships" id="275" r:id="Rcc3af5bc1bd54492"/>
   </p:sldIdLst>
   <p:sldSz cx="12192000" cy="6858000"/>
   <p:notesSz cx="6858000" cy="9144000"/>
@@ -2858,7 +2858,7 @@
           <p:nvPr/>
         </p:nvPicPr>
         <p:blipFill>
-          <a:blip xmlns:r="http://schemas.openxmlformats.org/officeDocument/2006/relationships" xmlns:a="http://schemas.openxmlformats.org/drawingml/2006/main" r:embed="R928a18544530494f"/>
+          <a:blip xmlns:r="http://schemas.openxmlformats.org/officeDocument/2006/relationships" xmlns:a="http://schemas.openxmlformats.org/drawingml/2006/main" r:embed="R8da3c9bcd0f84b53"/>
           <a:stretch xmlns:a="http://schemas.openxmlformats.org/drawingml/2006/main">
             <a:fillRect l="0" t="0" r="0" b="0"/>
           </a:stretch>
@@ -4919,7 +4919,7 @@
           <p:nvPr/>
         </p:nvPicPr>
         <p:blipFill>
-          <a:blip xmlns:r="http://schemas.openxmlformats.org/officeDocument/2006/relationships" xmlns:a="http://schemas.openxmlformats.org/drawingml/2006/main" r:embed="Rd30c18b903f44c2d"/>
+          <a:blip xmlns:r="http://schemas.openxmlformats.org/officeDocument/2006/relationships" xmlns:a="http://schemas.openxmlformats.org/drawingml/2006/main" r:embed="Reb11e874784e445b"/>
           <a:stretch xmlns:a="http://schemas.openxmlformats.org/drawingml/2006/main">
             <a:fillRect l="0" t="0" r="0" b="0"/>
           </a:stretch>
@@ -5345,7 +5345,7 @@
           <p:nvPr/>
         </p:nvPicPr>
         <p:blipFill>
-          <a:blip xmlns:r="http://schemas.openxmlformats.org/officeDocument/2006/relationships" xmlns:a="http://schemas.openxmlformats.org/drawingml/2006/main" r:embed="Red8476cfabed41fc"/>
+          <a:blip xmlns:r="http://schemas.openxmlformats.org/officeDocument/2006/relationships" xmlns:a="http://schemas.openxmlformats.org/drawingml/2006/main" r:embed="R6c49e54f65f54b04"/>
           <a:stretch xmlns:a="http://schemas.openxmlformats.org/drawingml/2006/main">
             <a:fillRect l="0" t="0" r="0" b="0"/>
           </a:stretch>
@@ -6555,7 +6555,7 @@
           <p:nvPr/>
         </p:nvPicPr>
         <p:blipFill>
-          <a:blip xmlns:r="http://schemas.openxmlformats.org/officeDocument/2006/relationships" xmlns:a="http://schemas.openxmlformats.org/drawingml/2006/main" r:embed="R531be39d3f4d4417"/>
+          <a:blip xmlns:r="http://schemas.openxmlformats.org/officeDocument/2006/relationships" xmlns:a="http://schemas.openxmlformats.org/drawingml/2006/main" r:embed="Rba291a2771514172"/>
           <a:stretch xmlns:a="http://schemas.openxmlformats.org/drawingml/2006/main">
             <a:fillRect l="0" t="0" r="0" b="0"/>
           </a:stretch>
@@ -7166,10 +7166,10 @@
   </p:cSld>
   <p:clrMap bg1="lt1" tx1="dk1" bg2="lt2" tx2="dk2" accent1="accent1" accent2="accent2" accent3="accent3" accent4="accent4" accent5="accent5" accent6="accent6" hlink="hlink" folHlink="folHlink"/>
   <p:sldLayoutIdLst>
-    <p:sldLayoutId xmlns:r="http://schemas.openxmlformats.org/officeDocument/2006/relationships" id="2147483649" r:id="R6774aaf4022f4dde"/>
-    <p:sldLayoutId xmlns:r="http://schemas.openxmlformats.org/officeDocument/2006/relationships" id="2147483650" r:id="R2907cd1275a145f0"/>
-    <p:sldLayoutId xmlns:r="http://schemas.openxmlformats.org/officeDocument/2006/relationships" id="2147483651" r:id="Rc07ac18b63374e4b"/>
-    <p:sldLayoutId xmlns:r="http://schemas.openxmlformats.org/officeDocument/2006/relationships" id="2147483652" r:id="R069991e97ab84089"/>
+    <p:sldLayoutId xmlns:r="http://schemas.openxmlformats.org/officeDocument/2006/relationships" id="2147483649" r:id="R229c5dc80b594cba"/>
+    <p:sldLayoutId xmlns:r="http://schemas.openxmlformats.org/officeDocument/2006/relationships" id="2147483650" r:id="Ra001d224962b4cf4"/>
+    <p:sldLayoutId xmlns:r="http://schemas.openxmlformats.org/officeDocument/2006/relationships" id="2147483651" r:id="R8e4ca8a7e7564fde"/>
+    <p:sldLayoutId xmlns:r="http://schemas.openxmlformats.org/officeDocument/2006/relationships" id="2147483652" r:id="Reaa0314c2ad243d1"/>
   </p:sldLayoutIdLst>
   <p:hf hdr="0" ftr="0" dt="0"/>
   <p:txStyles>
@@ -7932,7 +7932,7 @@
           <p:nvPr/>
         </p:nvPicPr>
         <p:blipFill>
-          <a:blip xmlns:r="http://schemas.openxmlformats.org/officeDocument/2006/relationships" xmlns:a="http://schemas.openxmlformats.org/drawingml/2006/main" r:embed="Rcec52703fe3a4ce6"/>
+          <a:blip xmlns:r="http://schemas.openxmlformats.org/officeDocument/2006/relationships" xmlns:a="http://schemas.openxmlformats.org/drawingml/2006/main" r:embed="R7b13c769019745ad"/>
           <a:stretch xmlns:a="http://schemas.openxmlformats.org/drawingml/2006/main">
             <a:fillRect l="0" t="0" r="0" b="0"/>
           </a:stretch>
@@ -8235,17 +8235,17 @@
   </p:cSld>
   <p:clrMap bg1="lt1" tx1="dk1" bg2="lt2" tx2="dk2" accent1="accent1" accent2="accent2" accent3="accent3" accent4="accent4" accent5="accent5" accent6="accent6" hlink="hlink" folHlink="folHlink"/>
   <p:sldLayoutIdLst>
-    <p:sldLayoutId xmlns:r="http://schemas.openxmlformats.org/officeDocument/2006/relationships" id="2147483654" r:id="R611ae9fdfc814c62"/>
-    <p:sldLayoutId xmlns:r="http://schemas.openxmlformats.org/officeDocument/2006/relationships" id="2147483655" r:id="Rf02677ac07e74a1d"/>
-    <p:sldLayoutId xmlns:r="http://schemas.openxmlformats.org/officeDocument/2006/relationships" id="2147483656" r:id="R6a04485c49aa4d1d"/>
-    <p:sldLayoutId xmlns:r="http://schemas.openxmlformats.org/officeDocument/2006/relationships" id="2147483657" r:id="R5106855820e247d9"/>
-    <p:sldLayoutId xmlns:r="http://schemas.openxmlformats.org/officeDocument/2006/relationships" id="2147483658" r:id="R7218614daae14abb"/>
-    <p:sldLayoutId xmlns:r="http://schemas.openxmlformats.org/officeDocument/2006/relationships" id="2147483659" r:id="R20530dce48bc4a0b"/>
-    <p:sldLayoutId xmlns:r="http://schemas.openxmlformats.org/officeDocument/2006/relationships" id="2147483660" r:id="R6b80278f2ea64335"/>
-    <p:sldLayoutId xmlns:r="http://schemas.openxmlformats.org/officeDocument/2006/relationships" id="2147483661" r:id="R90c7bc8638264ed2"/>
-    <p:sldLayoutId xmlns:r="http://schemas.openxmlformats.org/officeDocument/2006/relationships" id="2147483662" r:id="R8647a99860a8403c"/>
-    <p:sldLayoutId xmlns:r="http://schemas.openxmlformats.org/officeDocument/2006/relationships" id="2147483663" r:id="Rdcbed58325dd4af6"/>
-    <p:sldLayoutId xmlns:r="http://schemas.openxmlformats.org/officeDocument/2006/relationships" id="2147483664" r:id="R29f1df74458b4609"/>
+    <p:sldLayoutId xmlns:r="http://schemas.openxmlformats.org/officeDocument/2006/relationships" id="2147483654" r:id="Rc452f4d8acd64f39"/>
+    <p:sldLayoutId xmlns:r="http://schemas.openxmlformats.org/officeDocument/2006/relationships" id="2147483655" r:id="Rb6174b97e0c04896"/>
+    <p:sldLayoutId xmlns:r="http://schemas.openxmlformats.org/officeDocument/2006/relationships" id="2147483656" r:id="R4ad12d0b31424644"/>
+    <p:sldLayoutId xmlns:r="http://schemas.openxmlformats.org/officeDocument/2006/relationships" id="2147483657" r:id="R0e61c3c8e0c14672"/>
+    <p:sldLayoutId xmlns:r="http://schemas.openxmlformats.org/officeDocument/2006/relationships" id="2147483658" r:id="R4cb7a76857694604"/>
+    <p:sldLayoutId xmlns:r="http://schemas.openxmlformats.org/officeDocument/2006/relationships" id="2147483659" r:id="R6bba42d33e844de1"/>
+    <p:sldLayoutId xmlns:r="http://schemas.openxmlformats.org/officeDocument/2006/relationships" id="2147483660" r:id="Ree1d49af6b5848b6"/>
+    <p:sldLayoutId xmlns:r="http://schemas.openxmlformats.org/officeDocument/2006/relationships" id="2147483661" r:id="Rdd5115c85d6544ef"/>
+    <p:sldLayoutId xmlns:r="http://schemas.openxmlformats.org/officeDocument/2006/relationships" id="2147483662" r:id="R25feac06d606481d"/>
+    <p:sldLayoutId xmlns:r="http://schemas.openxmlformats.org/officeDocument/2006/relationships" id="2147483663" r:id="R7f60eb1991ad4ddb"/>
+    <p:sldLayoutId xmlns:r="http://schemas.openxmlformats.org/officeDocument/2006/relationships" id="2147483664" r:id="R3a4d7f08671f4e83"/>
   </p:sldLayoutIdLst>
   <p:hf hdr="0" ftr="0" dt="0"/>
   <p:txStyles>
@@ -9814,7 +9814,7 @@
           <p:nvPr/>
         </p:nvPicPr>
         <p:blipFill>
-          <a:blip xmlns:r="http://schemas.openxmlformats.org/officeDocument/2006/relationships" xmlns:a="http://schemas.openxmlformats.org/drawingml/2006/main" r:embed="R41eb5723eb874752"/>
+          <a:blip xmlns:r="http://schemas.openxmlformats.org/officeDocument/2006/relationships" xmlns:a="http://schemas.openxmlformats.org/drawingml/2006/main" r:embed="R457768594279449e"/>
           <a:stretch xmlns:a="http://schemas.openxmlformats.org/drawingml/2006/main"/>
         </p:blipFill>
         <p:spPr>
@@ -10167,7 +10167,7 @@
           <p:nvPr/>
         </p:nvPicPr>
         <p:blipFill>
-          <a:blip xmlns:r="http://schemas.openxmlformats.org/officeDocument/2006/relationships" xmlns:a="http://schemas.openxmlformats.org/drawingml/2006/main" r:embed="Rca2910752b5f4d2a"/>
+          <a:blip xmlns:r="http://schemas.openxmlformats.org/officeDocument/2006/relationships" xmlns:a="http://schemas.openxmlformats.org/drawingml/2006/main" r:embed="Rc39e2810605e44e8"/>
           <a:stretch xmlns:a="http://schemas.openxmlformats.org/drawingml/2006/main"/>
         </p:blipFill>
         <p:spPr>
@@ -10520,7 +10520,7 @@
           <p:nvPr/>
         </p:nvPicPr>
         <p:blipFill>
-          <a:blip xmlns:r="http://schemas.openxmlformats.org/officeDocument/2006/relationships" xmlns:a="http://schemas.openxmlformats.org/drawingml/2006/main" r:embed="R129e4362feae4e61"/>
+          <a:blip xmlns:r="http://schemas.openxmlformats.org/officeDocument/2006/relationships" xmlns:a="http://schemas.openxmlformats.org/drawingml/2006/main" r:embed="Rbc40232dddde413d"/>
           <a:stretch xmlns:a="http://schemas.openxmlformats.org/drawingml/2006/main"/>
         </p:blipFill>
         <p:spPr>
@@ -10873,7 +10873,7 @@
           <p:nvPr/>
         </p:nvPicPr>
         <p:blipFill>
-          <a:blip xmlns:r="http://schemas.openxmlformats.org/officeDocument/2006/relationships" xmlns:a="http://schemas.openxmlformats.org/drawingml/2006/main" r:embed="R627c7a3b93a446a1"/>
+          <a:blip xmlns:r="http://schemas.openxmlformats.org/officeDocument/2006/relationships" xmlns:a="http://schemas.openxmlformats.org/drawingml/2006/main" r:embed="Re3678205d7874a6a"/>
           <a:stretch xmlns:a="http://schemas.openxmlformats.org/drawingml/2006/main"/>
         </p:blipFill>
         <p:spPr>
@@ -11226,7 +11226,7 @@
           <p:nvPr/>
         </p:nvPicPr>
         <p:blipFill>
-          <a:blip xmlns:r="http://schemas.openxmlformats.org/officeDocument/2006/relationships" xmlns:a="http://schemas.openxmlformats.org/drawingml/2006/main" r:embed="R545a7d124f324195"/>
+          <a:blip xmlns:r="http://schemas.openxmlformats.org/officeDocument/2006/relationships" xmlns:a="http://schemas.openxmlformats.org/drawingml/2006/main" r:embed="R9cc76cdd77044dde"/>
           <a:stretch xmlns:a="http://schemas.openxmlformats.org/drawingml/2006/main"/>
         </p:blipFill>
         <p:spPr>
@@ -11579,7 +11579,7 @@
           <p:nvPr/>
         </p:nvPicPr>
         <p:blipFill>
-          <a:blip xmlns:r="http://schemas.openxmlformats.org/officeDocument/2006/relationships" xmlns:a="http://schemas.openxmlformats.org/drawingml/2006/main" r:embed="R9067587eee1c4f3f"/>
+          <a:blip xmlns:r="http://schemas.openxmlformats.org/officeDocument/2006/relationships" xmlns:a="http://schemas.openxmlformats.org/drawingml/2006/main" r:embed="R24a97d6f1afa4c0f"/>
           <a:stretch xmlns:a="http://schemas.openxmlformats.org/drawingml/2006/main"/>
         </p:blipFill>
         <p:spPr>
@@ -11932,7 +11932,7 @@
           <p:nvPr/>
         </p:nvPicPr>
         <p:blipFill>
-          <a:blip xmlns:r="http://schemas.openxmlformats.org/officeDocument/2006/relationships" xmlns:a="http://schemas.openxmlformats.org/drawingml/2006/main" r:embed="Rfac9d68941e84847"/>
+          <a:blip xmlns:r="http://schemas.openxmlformats.org/officeDocument/2006/relationships" xmlns:a="http://schemas.openxmlformats.org/drawingml/2006/main" r:embed="Rbaaca6a183574dc1"/>
           <a:stretch xmlns:a="http://schemas.openxmlformats.org/drawingml/2006/main"/>
         </p:blipFill>
         <p:spPr>
@@ -12285,7 +12285,7 @@
           <p:nvPr/>
         </p:nvPicPr>
         <p:blipFill>
-          <a:blip xmlns:r="http://schemas.openxmlformats.org/officeDocument/2006/relationships" xmlns:a="http://schemas.openxmlformats.org/drawingml/2006/main" r:embed="R5c0b466f190841ec"/>
+          <a:blip xmlns:r="http://schemas.openxmlformats.org/officeDocument/2006/relationships" xmlns:a="http://schemas.openxmlformats.org/drawingml/2006/main" r:embed="Rcb71b554bc824ec2"/>
           <a:stretch xmlns:a="http://schemas.openxmlformats.org/drawingml/2006/main"/>
         </p:blipFill>
         <p:spPr>
@@ -12638,7 +12638,7 @@
           <p:nvPr/>
         </p:nvPicPr>
         <p:blipFill>
-          <a:blip xmlns:r="http://schemas.openxmlformats.org/officeDocument/2006/relationships" xmlns:a="http://schemas.openxmlformats.org/drawingml/2006/main" r:embed="Ra733eb0fc8bb4aac"/>
+          <a:blip xmlns:r="http://schemas.openxmlformats.org/officeDocument/2006/relationships" xmlns:a="http://schemas.openxmlformats.org/drawingml/2006/main" r:embed="Rfac85f97c44446eb"/>
           <a:stretch xmlns:a="http://schemas.openxmlformats.org/drawingml/2006/main"/>
         </p:blipFill>
         <p:spPr>
@@ -12791,7 +12791,7 @@
           <p:nvPr/>
         </p:nvPicPr>
         <p:blipFill>
-          <a:blip xmlns:r="http://schemas.openxmlformats.org/officeDocument/2006/relationships" xmlns:a="http://schemas.openxmlformats.org/drawingml/2006/main" r:embed="R37717c8eb71a42f8"/>
+          <a:blip xmlns:r="http://schemas.openxmlformats.org/officeDocument/2006/relationships" xmlns:a="http://schemas.openxmlformats.org/drawingml/2006/main" r:embed="R40b80aebc6a442e2"/>
           <a:stretch xmlns:a="http://schemas.openxmlformats.org/drawingml/2006/main"/>
         </p:blipFill>
         <p:spPr>
@@ -13320,7 +13320,7 @@
           <p:nvPr/>
         </p:nvPicPr>
         <p:blipFill>
-          <a:blip xmlns:r="http://schemas.openxmlformats.org/officeDocument/2006/relationships" xmlns:a="http://schemas.openxmlformats.org/drawingml/2006/main" r:embed="R7e3b754568364ce2"/>
+          <a:blip xmlns:r="http://schemas.openxmlformats.org/officeDocument/2006/relationships" xmlns:a="http://schemas.openxmlformats.org/drawingml/2006/main" r:embed="R80df43fa5c9f41f3"/>
           <a:stretch xmlns:a="http://schemas.openxmlformats.org/drawingml/2006/main"/>
         </p:blipFill>
         <p:spPr>
@@ -13473,7 +13473,7 @@
           <p:nvPr/>
         </p:nvPicPr>
         <p:blipFill>
-          <a:blip xmlns:r="http://schemas.openxmlformats.org/officeDocument/2006/relationships" xmlns:a="http://schemas.openxmlformats.org/drawingml/2006/main" r:embed="R57a387d195ea4564"/>
+          <a:blip xmlns:r="http://schemas.openxmlformats.org/officeDocument/2006/relationships" xmlns:a="http://schemas.openxmlformats.org/drawingml/2006/main" r:embed="R43111897f9d24a68"/>
           <a:stretch xmlns:a="http://schemas.openxmlformats.org/drawingml/2006/main"/>
         </p:blipFill>
         <p:spPr>
@@ -13826,7 +13826,7 @@
           <p:nvPr/>
         </p:nvPicPr>
         <p:blipFill>
-          <a:blip xmlns:r="http://schemas.openxmlformats.org/officeDocument/2006/relationships" xmlns:a="http://schemas.openxmlformats.org/drawingml/2006/main" r:embed="R2aad5ad184304fe1"/>
+          <a:blip xmlns:r="http://schemas.openxmlformats.org/officeDocument/2006/relationships" xmlns:a="http://schemas.openxmlformats.org/drawingml/2006/main" r:embed="R965ff03ef2844d30"/>
           <a:stretch xmlns:a="http://schemas.openxmlformats.org/drawingml/2006/main"/>
         </p:blipFill>
         <p:spPr>
@@ -14179,7 +14179,7 @@
           <p:nvPr/>
         </p:nvPicPr>
         <p:blipFill>
-          <a:blip xmlns:r="http://schemas.openxmlformats.org/officeDocument/2006/relationships" xmlns:a="http://schemas.openxmlformats.org/drawingml/2006/main" r:embed="Rd009f345a0a84958"/>
+          <a:blip xmlns:r="http://schemas.openxmlformats.org/officeDocument/2006/relationships" xmlns:a="http://schemas.openxmlformats.org/drawingml/2006/main" r:embed="R7292e237de9940c4"/>
           <a:stretch xmlns:a="http://schemas.openxmlformats.org/drawingml/2006/main"/>
         </p:blipFill>
         <p:spPr>
@@ -14532,7 +14532,7 @@
           <p:nvPr/>
         </p:nvPicPr>
         <p:blipFill>
-          <a:blip xmlns:r="http://schemas.openxmlformats.org/officeDocument/2006/relationships" xmlns:a="http://schemas.openxmlformats.org/drawingml/2006/main" r:embed="Rf2424530150f4d41"/>
+          <a:blip xmlns:r="http://schemas.openxmlformats.org/officeDocument/2006/relationships" xmlns:a="http://schemas.openxmlformats.org/drawingml/2006/main" r:embed="Ref07c344f4da46ab"/>
           <a:stretch xmlns:a="http://schemas.openxmlformats.org/drawingml/2006/main"/>
         </p:blipFill>
         <p:spPr>
@@ -14885,7 +14885,7 @@
           <p:nvPr/>
         </p:nvPicPr>
         <p:blipFill>
-          <a:blip xmlns:r="http://schemas.openxmlformats.org/officeDocument/2006/relationships" xmlns:a="http://schemas.openxmlformats.org/drawingml/2006/main" r:embed="Rd1d12e4e8f75484f"/>
+          <a:blip xmlns:r="http://schemas.openxmlformats.org/officeDocument/2006/relationships" xmlns:a="http://schemas.openxmlformats.org/drawingml/2006/main" r:embed="R938b626be1dd45a0"/>
           <a:stretch xmlns:a="http://schemas.openxmlformats.org/drawingml/2006/main"/>
         </p:blipFill>
         <p:spPr>
@@ -15238,7 +15238,7 @@
           <p:nvPr/>
         </p:nvPicPr>
         <p:blipFill>
-          <a:blip xmlns:r="http://schemas.openxmlformats.org/officeDocument/2006/relationships" xmlns:a="http://schemas.openxmlformats.org/drawingml/2006/main" r:embed="Rb7b2c1b6e5f04f13"/>
+          <a:blip xmlns:r="http://schemas.openxmlformats.org/officeDocument/2006/relationships" xmlns:a="http://schemas.openxmlformats.org/drawingml/2006/main" r:embed="Rd08a045d5f184dfd"/>
           <a:stretch xmlns:a="http://schemas.openxmlformats.org/drawingml/2006/main"/>
         </p:blipFill>
         <p:spPr>

</xml_diff>